<commit_message>
Checkpoint current paper and figure revisions
</commit_message>
<xml_diff>
--- a/27cvpr/ppt/ppt/fig1_v8.pptx
+++ b/27cvpr/ppt/ppt/fig1_v8.pptx
@@ -12786,7 +12786,7 @@
       </p:sp>
       <p:sp>
         <p:nvSpPr>
-          <p:cNvPr id="201" name="Label: Task loss (Stage 1)"/>
+          <p:cNvPr id="201" name="Label: Task loss"/>
           <p:cNvSpPr txBox="1"/>
           <p:nvPr/>
         </p:nvSpPr>
@@ -12825,7 +12825,7 @@
                 </a:solidFill>
                 <a:latin typeface="Comic Sans MS"/>
               </a:rPr>
-              <a:t>Task loss (Stage 1)</a:t>
+              <a:t>Task loss</a:t>
             </a:r>
           </a:p>
         </p:txBody>

</xml_diff>